<commit_message>
Template: strip document metadata
make_template.py now sets the core-properties author and last editor to
"RFQ Insight", drops lastPrinted, removes docProps/custom.xml (sensitivity
label data) and the customXml parts with their relationships and overrides,
and replaces the author/department/date text in the master footer and the
layout author boxes. No personal name remains in the asset.

Co-Authored-By: Claude Fable 5.1 <noreply@anthropic.com>
Claude-Session: https://claude.ai/code/session_013fhANV3ZChMBGL4i5PTBxW
</commit_message>
<xml_diff>
--- a/plugins/rfq-insight/skills/rfq-insight/assets/avl_template.pptx
+++ b/plugins/rfq-insight/skills/rfq-insight/assets/avl_template.pptx
@@ -919,7 +919,7 @@
                 <a:ea typeface="Verdana" panose="020B0604030504040204" pitchFamily="34" charset="0"/>
                 <a:cs typeface="Verdana" panose="020B0604030504040204" pitchFamily="34" charset="0"/>
               </a:rPr>
-              <a:t>K. Petinger</a:t>
+              <a:t>RFQ Insight</a:t>
             </a:r>
             <a:endParaRPr lang="en-US" sz="1400" b="0" kern="1200" baseline="0" dirty="0">
               <a:solidFill>
@@ -4112,7 +4112,7 @@
                           <a:ea typeface="Verdana" panose="020B0604030504040204" pitchFamily="34" charset="0"/>
                           <a:cs typeface="Verdana" panose="020B0604030504040204" pitchFamily="34" charset="0"/>
                         </a:rPr>
-                        <a:t>K. Petinger</a:t>
+                        <a:t>RFQ Insight</a:t>
                       </a:r>
                       <a:endParaRPr kumimoji="0" lang="de-DE" sz="1200" b="0" i="0" u="none" strike="noStrike" cap="none" normalizeH="0" baseline="0" noProof="0" dirty="0">
                         <a:ln>
@@ -5793,7 +5793,7 @@
                           <a:ea typeface="Verdana" panose="020B0604030504040204" pitchFamily="34" charset="0"/>
                           <a:cs typeface="Verdana" panose="020B0604030504040204" pitchFamily="34" charset="0"/>
                         </a:rPr>
-                        <a:t>LBP</a:t>
+                        <a:t/>
                       </a:r>
                       <a:endParaRPr kumimoji="0" lang="en-GB" sz="1200" b="0" i="0" u="none" strike="noStrike" cap="none" normalizeH="0" baseline="0" noProof="0" dirty="0">
                         <a:ln>
@@ -25812,7 +25812,7 @@
                 <a:ea typeface="Verdana" panose="020B0604030504040204" pitchFamily="34" charset="0"/>
                 <a:cs typeface="Verdana" panose="020B0604030504040204" pitchFamily="34" charset="0"/>
               </a:rPr>
-              <a:t>K. Petinger | LBP | 23 Oktober 2026 |</a:t>
+              <a:t>RFQ Insight</a:t>
             </a:r>
             <a:endParaRPr lang="en-GB" sz="1000" dirty="0">
               <a:solidFill>
@@ -27444,248 +27444,4 @@
   <a:objectDefaults/>
   <a:extraClrSchemeLst/>
 </a:theme>
-</file>
-
-<file path=customXml/item1.xml><?xml version="1.0" encoding="utf-8"?>
-<ct:contentTypeSchema xmlns:ct="http://schemas.microsoft.com/office/2006/metadata/contentType" xmlns:ma="http://schemas.microsoft.com/office/2006/metadata/properties/metaAttributes" ct:_="" ma:_="" ma:contentTypeName="Document" ma:contentTypeID="0x01010070BBB18F0ACF6942BEBAA5C2AAEB6AB4" ma:contentTypeVersion="11" ma:contentTypeDescription="Create a new document." ma:contentTypeScope="" ma:versionID="8dfbd93d459898f85cf467ee1d2ca8f4">
-  <xsd:schema xmlns:xsd="http://www.w3.org/2001/XMLSchema" xmlns:xs="http://www.w3.org/2001/XMLSchema" xmlns:p="http://schemas.microsoft.com/office/2006/metadata/properties" xmlns:ns2="afba092a-8b91-4dfb-992b-2bbae6fd1299" xmlns:ns3="b782677f-2de5-4c9f-82d8-ffa3861de47a" targetNamespace="http://schemas.microsoft.com/office/2006/metadata/properties" ma:root="true" ma:fieldsID="22f4bd1413753eba9ac9c64748a7df9d" ns2:_="" ns3:_="">
-    <xsd:import namespace="afba092a-8b91-4dfb-992b-2bbae6fd1299"/>
-    <xsd:import namespace="b782677f-2de5-4c9f-82d8-ffa3861de47a"/>
-    <xsd:element name="properties">
-      <xsd:complexType>
-        <xsd:sequence>
-          <xsd:element name="documentManagement">
-            <xsd:complexType>
-              <xsd:all>
-                <xsd:element ref="ns2:MediaServiceMetadata" minOccurs="0"/>
-                <xsd:element ref="ns2:MediaServiceFastMetadata" minOccurs="0"/>
-                <xsd:element ref="ns2:MediaServiceSearchProperties" minOccurs="0"/>
-                <xsd:element ref="ns2:MediaServiceGenerationTime" minOccurs="0"/>
-                <xsd:element ref="ns2:MediaServiceEventHashCode" minOccurs="0"/>
-                <xsd:element ref="ns2:MediaServiceDateTaken" minOccurs="0"/>
-                <xsd:element ref="ns2:lcf76f155ced4ddcb4097134ff3c332f" minOccurs="0"/>
-                <xsd:element ref="ns3:TaxCatchAll" minOccurs="0"/>
-                <xsd:element ref="ns2:MediaServiceOCR" minOccurs="0"/>
-                <xsd:element ref="ns2:MediaServiceBillingMetadata" minOccurs="0"/>
-              </xsd:all>
-            </xsd:complexType>
-          </xsd:element>
-        </xsd:sequence>
-      </xsd:complexType>
-    </xsd:element>
-  </xsd:schema>
-  <xsd:schema xmlns:xsd="http://www.w3.org/2001/XMLSchema" xmlns:xs="http://www.w3.org/2001/XMLSchema" xmlns:dms="http://schemas.microsoft.com/office/2006/documentManagement/types" xmlns:pc="http://schemas.microsoft.com/office/infopath/2007/PartnerControls" targetNamespace="afba092a-8b91-4dfb-992b-2bbae6fd1299" elementFormDefault="qualified">
-    <xsd:import namespace="http://schemas.microsoft.com/office/2006/documentManagement/types"/>
-    <xsd:import namespace="http://schemas.microsoft.com/office/infopath/2007/PartnerControls"/>
-    <xsd:element name="MediaServiceMetadata" ma:index="8" nillable="true" ma:displayName="MediaServiceMetadata" ma:hidden="true" ma:internalName="MediaServiceMetadata" ma:readOnly="true">
-      <xsd:simpleType>
-        <xsd:restriction base="dms:Note"/>
-      </xsd:simpleType>
-    </xsd:element>
-    <xsd:element name="MediaServiceFastMetadata" ma:index="9" nillable="true" ma:displayName="MediaServiceFastMetadata" ma:hidden="true" ma:internalName="MediaServiceFastMetadata" ma:readOnly="true">
-      <xsd:simpleType>
-        <xsd:restriction base="dms:Note"/>
-      </xsd:simpleType>
-    </xsd:element>
-    <xsd:element name="MediaServiceSearchProperties" ma:index="10" nillable="true" ma:displayName="MediaServiceSearchProperties" ma:hidden="true" ma:internalName="MediaServiceSearchProperties" ma:readOnly="true">
-      <xsd:simpleType>
-        <xsd:restriction base="dms:Note"/>
-      </xsd:simpleType>
-    </xsd:element>
-    <xsd:element name="MediaServiceGenerationTime" ma:index="11" nillable="true" ma:displayName="MediaServiceGenerationTime" ma:hidden="true" ma:internalName="MediaServiceGenerationTime" ma:readOnly="true">
-      <xsd:simpleType>
-        <xsd:restriction base="dms:Text"/>
-      </xsd:simpleType>
-    </xsd:element>
-    <xsd:element name="MediaServiceEventHashCode" ma:index="12" nillable="true" ma:displayName="MediaServiceEventHashCode" ma:hidden="true" ma:internalName="MediaServiceEventHashCode" ma:readOnly="true">
-      <xsd:simpleType>
-        <xsd:restriction base="dms:Text"/>
-      </xsd:simpleType>
-    </xsd:element>
-    <xsd:element name="MediaServiceDateTaken" ma:index="13" nillable="true" ma:displayName="MediaServiceDateTaken" ma:hidden="true" ma:indexed="true" ma:internalName="MediaServiceDateTaken" ma:readOnly="true">
-      <xsd:simpleType>
-        <xsd:restriction base="dms:Text"/>
-      </xsd:simpleType>
-    </xsd:element>
-    <xsd:element name="lcf76f155ced4ddcb4097134ff3c332f" ma:index="15" nillable="true" ma:taxonomy="true" ma:internalName="lcf76f155ced4ddcb4097134ff3c332f" ma:taxonomyFieldName="MediaServiceImageTags" ma:displayName="Image Tags" ma:readOnly="false" ma:fieldId="{5cf76f15-5ced-4ddc-b409-7134ff3c332f}" ma:taxonomyMulti="true" ma:sspId="604717e6-17bb-4eb5-b706-c15648a3c862" ma:termSetId="09814cd3-568e-fe90-9814-8d621ff8fb84" ma:anchorId="fba54fb3-c3e1-fe81-a776-ca4b69148c4d" ma:open="true" ma:isKeyword="false">
-      <xsd:complexType>
-        <xsd:sequence>
-          <xsd:element ref="pc:Terms" minOccurs="0" maxOccurs="1"/>
-        </xsd:sequence>
-      </xsd:complexType>
-    </xsd:element>
-    <xsd:element name="MediaServiceOCR" ma:index="17" nillable="true" ma:displayName="Extracted Text" ma:internalName="MediaServiceOCR" ma:readOnly="true">
-      <xsd:simpleType>
-        <xsd:restriction base="dms:Note">
-          <xsd:maxLength value="255"/>
-        </xsd:restriction>
-      </xsd:simpleType>
-    </xsd:element>
-    <xsd:element name="MediaServiceBillingMetadata" ma:index="18" nillable="true" ma:displayName="MediaServiceBillingMetadata" ma:hidden="true" ma:internalName="MediaServiceBillingMetadata" ma:readOnly="true">
-      <xsd:simpleType>
-        <xsd:restriction base="dms:Note"/>
-      </xsd:simpleType>
-    </xsd:element>
-  </xsd:schema>
-  <xsd:schema xmlns:xsd="http://www.w3.org/2001/XMLSchema" xmlns:xs="http://www.w3.org/2001/XMLSchema" xmlns:dms="http://schemas.microsoft.com/office/2006/documentManagement/types" xmlns:pc="http://schemas.microsoft.com/office/infopath/2007/PartnerControls" targetNamespace="b782677f-2de5-4c9f-82d8-ffa3861de47a" elementFormDefault="qualified">
-    <xsd:import namespace="http://schemas.microsoft.com/office/2006/documentManagement/types"/>
-    <xsd:import namespace="http://schemas.microsoft.com/office/infopath/2007/PartnerControls"/>
-    <xsd:element name="TaxCatchAll" ma:index="16" nillable="true" ma:displayName="Taxonomy Catch All Column" ma:hidden="true" ma:list="{654ceaae-3c0a-445b-8a85-bc227b867eac}" ma:internalName="TaxCatchAll" ma:showField="CatchAllData" ma:web="b782677f-2de5-4c9f-82d8-ffa3861de47a">
-      <xsd:complexType>
-        <xsd:complexContent>
-          <xsd:extension base="dms:MultiChoiceLookup">
-            <xsd:sequence>
-              <xsd:element name="Value" type="dms:Lookup" maxOccurs="unbounded" minOccurs="0" nillable="true"/>
-            </xsd:sequence>
-          </xsd:extension>
-        </xsd:complexContent>
-      </xsd:complexType>
-    </xsd:element>
-  </xsd:schema>
-  <xsd:schema xmlns="http://schemas.openxmlformats.org/package/2006/metadata/core-properties" xmlns:xsd="http://www.w3.org/2001/XMLSchema" xmlns:xsi="http://www.w3.org/2001/XMLSchema-instance" xmlns:dc="http://purl.org/dc/elements/1.1/" xmlns:dcterms="http://purl.org/dc/terms/" xmlns:odoc="http://schemas.microsoft.com/internal/obd" targetNamespace="http://schemas.openxmlformats.org/package/2006/metadata/core-properties" elementFormDefault="qualified" attributeFormDefault="unqualified" blockDefault="#all">
-    <xsd:import namespace="http://purl.org/dc/elements/1.1/" schemaLocation="http://dublincore.org/schemas/xmls/qdc/2003/04/02/dc.xsd"/>
-    <xsd:import namespace="http://purl.org/dc/terms/" schemaLocation="http://dublincore.org/schemas/xmls/qdc/2003/04/02/dcterms.xsd"/>
-    <xsd:element name="coreProperties" type="CT_coreProperties"/>
-    <xsd:complexType name="CT_coreProperties">
-      <xsd:all>
-        <xsd:element ref="dc:creator" minOccurs="0" maxOccurs="1"/>
-        <xsd:element ref="dcterms:created" minOccurs="0" maxOccurs="1"/>
-        <xsd:element ref="dc:identifier" minOccurs="0" maxOccurs="1"/>
-        <xsd:element name="contentType" minOccurs="0" maxOccurs="1" type="xsd:string" ma:index="0" ma:displayName="Content Type"/>
-        <xsd:element ref="dc:title" minOccurs="0" maxOccurs="1" ma:index="4" ma:displayName="Title"/>
-        <xsd:element ref="dc:subject" minOccurs="0" maxOccurs="1"/>
-        <xsd:element ref="dc:description" minOccurs="0" maxOccurs="1"/>
-        <xsd:element name="keywords" minOccurs="0" maxOccurs="1" type="xsd:string"/>
-        <xsd:element ref="dc:language" minOccurs="0" maxOccurs="1"/>
-        <xsd:element name="category" minOccurs="0" maxOccurs="1" type="xsd:string"/>
-        <xsd:element name="version" minOccurs="0" maxOccurs="1" type="xsd:string"/>
-        <xsd:element name="revision" minOccurs="0" maxOccurs="1" type="xsd:string">
-          <xsd:annotation>
-            <xsd:documentation>
-                        This value indicates the number of saves or revisions. The application is responsible for updating this value after each revision.
-                    </xsd:documentation>
-          </xsd:annotation>
-        </xsd:element>
-        <xsd:element name="lastModifiedBy" minOccurs="0" maxOccurs="1" type="xsd:string"/>
-        <xsd:element ref="dcterms:modified" minOccurs="0" maxOccurs="1"/>
-        <xsd:element name="contentStatus" minOccurs="0" maxOccurs="1" type="xsd:string"/>
-      </xsd:all>
-    </xsd:complexType>
-  </xsd:schema>
-  <xs:schema xmlns:pc="http://schemas.microsoft.com/office/infopath/2007/PartnerControls" xmlns:xs="http://www.w3.org/2001/XMLSchema" targetNamespace="http://schemas.microsoft.com/office/infopath/2007/PartnerControls" elementFormDefault="qualified" attributeFormDefault="unqualified">
-    <xs:element name="Person">
-      <xs:complexType>
-        <xs:sequence>
-          <xs:element ref="pc:DisplayName" minOccurs="0"/>
-          <xs:element ref="pc:AccountId" minOccurs="0"/>
-          <xs:element ref="pc:AccountType" minOccurs="0"/>
-        </xs:sequence>
-      </xs:complexType>
-    </xs:element>
-    <xs:element name="DisplayName" type="xs:string"/>
-    <xs:element name="AccountId" type="xs:string"/>
-    <xs:element name="AccountType" type="xs:string"/>
-    <xs:element name="BDCAssociatedEntity">
-      <xs:complexType>
-        <xs:sequence>
-          <xs:element ref="pc:BDCEntity" minOccurs="0" maxOccurs="unbounded"/>
-        </xs:sequence>
-        <xs:attribute ref="pc:EntityNamespace"/>
-        <xs:attribute ref="pc:EntityName"/>
-        <xs:attribute ref="pc:SystemInstanceName"/>
-        <xs:attribute ref="pc:AssociationName"/>
-      </xs:complexType>
-    </xs:element>
-    <xs:attribute name="EntityNamespace" type="xs:string"/>
-    <xs:attribute name="EntityName" type="xs:string"/>
-    <xs:attribute name="SystemInstanceName" type="xs:string"/>
-    <xs:attribute name="AssociationName" type="xs:string"/>
-    <xs:element name="BDCEntity">
-      <xs:complexType>
-        <xs:sequence>
-          <xs:element ref="pc:EntityDisplayName" minOccurs="0"/>
-          <xs:element ref="pc:EntityInstanceReference" minOccurs="0"/>
-          <xs:element ref="pc:EntityId1" minOccurs="0"/>
-          <xs:element ref="pc:EntityId2" minOccurs="0"/>
-          <xs:element ref="pc:EntityId3" minOccurs="0"/>
-          <xs:element ref="pc:EntityId4" minOccurs="0"/>
-          <xs:element ref="pc:EntityId5" minOccurs="0"/>
-        </xs:sequence>
-      </xs:complexType>
-    </xs:element>
-    <xs:element name="EntityDisplayName" type="xs:string"/>
-    <xs:element name="EntityInstanceReference" type="xs:string"/>
-    <xs:element name="EntityId1" type="xs:string"/>
-    <xs:element name="EntityId2" type="xs:string"/>
-    <xs:element name="EntityId3" type="xs:string"/>
-    <xs:element name="EntityId4" type="xs:string"/>
-    <xs:element name="EntityId5" type="xs:string"/>
-    <xs:element name="Terms">
-      <xs:complexType>
-        <xs:sequence>
-          <xs:element ref="pc:TermInfo" minOccurs="0" maxOccurs="unbounded"/>
-        </xs:sequence>
-      </xs:complexType>
-    </xs:element>
-    <xs:element name="TermInfo">
-      <xs:complexType>
-        <xs:sequence>
-          <xs:element ref="pc:TermName" minOccurs="0"/>
-          <xs:element ref="pc:TermId" minOccurs="0"/>
-        </xs:sequence>
-      </xs:complexType>
-    </xs:element>
-    <xs:element name="TermName" type="xs:string"/>
-    <xs:element name="TermId" type="xs:string"/>
-  </xs:schema>
-</ct:contentTypeSchema>
-</file>
-
-<file path=customXml/item2.xml><?xml version="1.0" encoding="utf-8"?>
-<p:properties xmlns:p="http://schemas.microsoft.com/office/2006/metadata/properties" xmlns:xsi="http://www.w3.org/2001/XMLSchema-instance" xmlns:pc="http://schemas.microsoft.com/office/infopath/2007/PartnerControls">
-  <documentManagement>
-    <lcf76f155ced4ddcb4097134ff3c332f xmlns="afba092a-8b91-4dfb-992b-2bbae6fd1299">
-      <Terms xmlns="http://schemas.microsoft.com/office/infopath/2007/PartnerControls"/>
-    </lcf76f155ced4ddcb4097134ff3c332f>
-    <TaxCatchAll xmlns="b782677f-2de5-4c9f-82d8-ffa3861de47a" xsi:nil="true"/>
-  </documentManagement>
-</p:properties>
-</file>
-
-<file path=customXml/item3.xml><?xml version="1.0" encoding="utf-8"?>
-<?mso-contentType ?>
-<FormTemplates xmlns="http://schemas.microsoft.com/sharepoint/v3/contenttype/forms">
-  <Display>DocumentLibraryForm</Display>
-  <Edit>DocumentLibraryForm</Edit>
-  <New>DocumentLibraryForm</New>
-</FormTemplates>
-</file>
-
-<file path=customXml/itemProps1.xml><?xml version="1.0" encoding="utf-8"?>
-<ds:datastoreItem xmlns:ds="http://schemas.openxmlformats.org/officeDocument/2006/customXml" ds:itemID="{294670B6-1EBD-42A7-9CA4-AB86235BBF7D}"/>
-</file>
-
-<file path=customXml/itemProps2.xml><?xml version="1.0" encoding="utf-8"?>
-<ds:datastoreItem xmlns:ds="http://schemas.openxmlformats.org/officeDocument/2006/customXml" ds:itemID="{C4288C4A-632E-4A16-BA4D-15894B511EE3}">
-  <ds:schemaRefs>
-    <ds:schemaRef ds:uri="http://purl.org/dc/elements/1.1/"/>
-    <ds:schemaRef ds:uri="http://schemas.microsoft.com/office/2006/metadata/properties"/>
-    <ds:schemaRef ds:uri="b782677f-2de5-4c9f-82d8-ffa3861de47a"/>
-    <ds:schemaRef ds:uri="http://purl.org/dc/terms/"/>
-    <ds:schemaRef ds:uri="afba092a-8b91-4dfb-992b-2bbae6fd1299"/>
-    <ds:schemaRef ds:uri="http://schemas.microsoft.com/office/2006/documentManagement/types"/>
-    <ds:schemaRef ds:uri="http://schemas.microsoft.com/office/infopath/2007/PartnerControls"/>
-    <ds:schemaRef ds:uri="http://schemas.openxmlformats.org/package/2006/metadata/core-properties"/>
-    <ds:schemaRef ds:uri="http://www.w3.org/XML/1998/namespace"/>
-    <ds:schemaRef ds:uri="http://purl.org/dc/dcmitype/"/>
-  </ds:schemaRefs>
-</ds:datastoreItem>
-</file>
-
-<file path=customXml/itemProps3.xml><?xml version="1.0" encoding="utf-8"?>
-<ds:datastoreItem xmlns:ds="http://schemas.openxmlformats.org/officeDocument/2006/customXml" ds:itemID="{A6F63D92-B53C-456D-AB7F-9CF942B25EC2}">
-  <ds:schemaRefs>
-    <ds:schemaRef ds:uri="http://schemas.microsoft.com/sharepoint/v3/contenttype/forms"/>
-  </ds:schemaRefs>
-</ds:datastoreItem>
 </file>
</xml_diff>

<commit_message>
Template: scrub names generically
Replace the literal author strings with rules that work for any source deck:
on the master and every layout, blank non-placeholder text boxes whose text
contains "|" and boxes named txt_Autor*, and blank the values (keep the
labels) of tbl_Info info tables. The creator and last-modified-by values of
the source core.xml are read first and the build raises ValueError, naming
the part, if either still appears in any output XML part. The tests build a
synthetic deck instead of naming the real author.

Co-Authored-By: Claude Fable 5.1 <noreply@anthropic.com>
Claude-Session: https://claude.ai/code/session_013fhANV3ZChMBGL4i5PTBxW
</commit_message>
<xml_diff>
--- a/plugins/rfq-insight/skills/rfq-insight/assets/avl_template.pptx
+++ b/plugins/rfq-insight/skills/rfq-insight/assets/avl_template.pptx
@@ -919,7 +919,7 @@
                 <a:ea typeface="Verdana" panose="020B0604030504040204" pitchFamily="34" charset="0"/>
                 <a:cs typeface="Verdana" panose="020B0604030504040204" pitchFamily="34" charset="0"/>
               </a:rPr>
-              <a:t>RFQ Insight</a:t>
+              <a:t/>
             </a:r>
             <a:endParaRPr lang="en-US" sz="1400" b="0" kern="1200" baseline="0" dirty="0">
               <a:solidFill>
@@ -4112,7 +4112,7 @@
                           <a:ea typeface="Verdana" panose="020B0604030504040204" pitchFamily="34" charset="0"/>
                           <a:cs typeface="Verdana" panose="020B0604030504040204" pitchFamily="34" charset="0"/>
                         </a:rPr>
-                        <a:t>RFQ Insight</a:t>
+                        <a:t/>
                       </a:r>
                       <a:endParaRPr kumimoji="0" lang="de-DE" sz="1200" b="0" i="0" u="none" strike="noStrike" cap="none" normalizeH="0" baseline="0" noProof="0" dirty="0">
                         <a:ln>
@@ -4776,7 +4776,7 @@
                           <a:ea typeface="Verdana" panose="020B0604030504040204" pitchFamily="34" charset="0"/>
                           <a:cs typeface="Verdana" panose="020B0604030504040204" pitchFamily="34" charset="0"/>
                         </a:rPr>
-                        <a:t>1.0</a:t>
+                        <a:t/>
                       </a:r>
                       <a:endParaRPr kumimoji="0" lang="en-GB" sz="1200" b="0" i="0" u="none" strike="noStrike" cap="none" normalizeH="0" baseline="0" noProof="0" dirty="0">
                         <a:ln>
@@ -4953,7 +4953,7 @@
                           <a:ea typeface="Verdana" panose="020B0604030504040204" pitchFamily="34" charset="0"/>
                           <a:cs typeface="Verdana" panose="020B0604030504040204" pitchFamily="34" charset="0"/>
                         </a:rPr>
-                        <a:t>23.10.2026</a:t>
+                        <a:t/>
                       </a:r>
                       <a:endParaRPr kumimoji="0" lang="en-GB" sz="1200" b="0" i="0" u="none" strike="noStrike" cap="none" normalizeH="0" baseline="0" noProof="0" dirty="0">
                         <a:ln>
@@ -5130,7 +5130,7 @@
                           <a:ea typeface="Verdana" panose="020B0604030504040204" pitchFamily="34" charset="0"/>
                           <a:cs typeface="Verdana" panose="020B0604030504040204" pitchFamily="34" charset="0"/>
                         </a:rPr>
-                        <a:t>Internal</a:t>
+                        <a:t/>
                       </a:r>
                       <a:endParaRPr kumimoji="0" lang="en-GB" sz="1200" b="0" i="0" u="none" strike="noStrike" cap="none" normalizeH="0" baseline="0" noProof="0" dirty="0">
                         <a:ln>
@@ -25812,7 +25812,7 @@
                 <a:ea typeface="Verdana" panose="020B0604030504040204" pitchFamily="34" charset="0"/>
                 <a:cs typeface="Verdana" panose="020B0604030504040204" pitchFamily="34" charset="0"/>
               </a:rPr>
-              <a:t>RFQ Insight</a:t>
+              <a:t/>
             </a:r>
             <a:endParaRPr lang="en-GB" sz="1000" dirty="0">
               <a:solidFill>

</xml_diff>